<commit_message>
chore(preview): MSFT outputs regeneres
</commit_message>
<xml_diff>
--- a/preview/MSFT/MSFT_pitchbook.pptx
+++ b/preview/MSFT/MSFT_pitchbook.pptx
@@ -14850,7 +14850,7 @@
                 </a:solidFill>
                 <a:latin typeface="Calibri"/>
               </a:rPr>
-              <a:t>Score agrégé : +0,308</a:t>
+              <a:t>Score agrégé : +0,361</a:t>
             </a:r>
           </a:p>
         </p:txBody>
@@ -15162,7 +15162,7 @@
                 </a:solidFill>
                 <a:latin typeface="Calibri"/>
               </a:rPr>
-              <a:t>55,1 %</a:t>
+              <a:t>55,8 %</a:t>
             </a:r>
           </a:p>
         </p:txBody>
@@ -15641,7 +15641,7 @@
                           </a:solidFill>
                           <a:latin typeface="Calibri"/>
                         </a:rPr>
-                        <a:t>+0,551</a:t>
+                        <a:t>+0,558</a:t>
                       </a:r>
                     </a:p>
                   </a:txBody>
@@ -15712,7 +15712,7 @@
                           </a:solidFill>
                           <a:latin typeface="Calibri"/>
                         </a:rPr>
-                        <a:t>3</a:t>
+                        <a:t>5</a:t>
                       </a:r>
                     </a:p>
                   </a:txBody>
@@ -15735,7 +15735,7 @@
                           </a:solidFill>
                           <a:latin typeface="Calibri"/>
                         </a:rPr>
-                        <a:t>+0,206</a:t>
+                        <a:t>+0,246</a:t>
                       </a:r>
                     </a:p>
                   </a:txBody>
@@ -15806,7 +15806,7 @@
                           </a:solidFill>
                           <a:latin typeface="Calibri"/>
                         </a:rPr>
-                        <a:t>7</a:t>
+                        <a:t>5</a:t>
                       </a:r>
                     </a:p>
                   </a:txBody>
@@ -15829,7 +15829,7 @@
                           </a:solidFill>
                           <a:latin typeface="Calibri"/>
                         </a:rPr>
-                        <a:t>+0,243</a:t>
+                        <a:t>+0,196</a:t>
                       </a:r>
                     </a:p>
                   </a:txBody>
@@ -15897,7 +15897,7 @@
                 </a:solidFill>
                 <a:latin typeface="Calibri"/>
               </a:rPr>
-              <a:t>La presse financière salue les partenariats stratégiques et l'innovation d'Anthropic soutenus par Microsoft, mais reste prudente face à la baisse récente du titre. L'accent sur l'IA et la cybersécurité renforce l'optimisme, malgré les tensions géopolitiques.</a:t>
+              <a:t>La presse financière salue massivement les partenariats stratégiques et l’avancée technologique d’Anthropic, où Microsoft joue un rôle clé. Cependant, la tendance baissière récente du titre et les incertitudes géopolitiques freinent l’enthousiasme global.</a:t>
             </a:r>
           </a:p>
         </p:txBody>
@@ -21191,7 +21191,7 @@
                 </a:solidFill>
                 <a:latin typeface="Calibri"/>
               </a:rPr>
-              <a:t>+0,308</a:t>
+              <a:t>+0,361</a:t>
             </a:r>
           </a:p>
         </p:txBody>

</xml_diff>